<commit_message>
more changes to figure 2
</commit_message>
<xml_diff>
--- a/manuscript-figures/figure2.pptx
+++ b/manuscript-figures/figure2.pptx
@@ -2,18 +2,19 @@
 <file path=ppt/presentation.xml><?xml version="1.0" encoding="utf-8"?>
 <p:presentation xmlns:a="http://schemas.openxmlformats.org/drawingml/2006/main" xmlns:r="http://schemas.openxmlformats.org/officeDocument/2006/relationships" xmlns:p="http://schemas.openxmlformats.org/presentationml/2006/main" saveSubsetFonts="1" autoCompressPictures="0">
   <p:sldMasterIdLst>
-    <p:sldMasterId id="2147483648" r:id="rId1"/>
+    <p:sldMasterId id="2147483660" r:id="rId1"/>
   </p:sldMasterIdLst>
   <p:sldIdLst>
     <p:sldId id="256" r:id="rId2"/>
+    <p:sldId id="257" r:id="rId3"/>
   </p:sldIdLst>
-  <p:sldSz cx="12192000" cy="6858000"/>
+  <p:sldSz cx="9144000" cy="6858000" type="letter"/>
   <p:notesSz cx="6858000" cy="9144000"/>
   <p:defaultTextStyle>
     <a:defPPr>
       <a:defRPr lang="en-US"/>
     </a:defPPr>
-    <a:lvl1pPr marL="0" algn="l" defTabSz="914400" rtl="0" eaLnBrk="1" latinLnBrk="0" hangingPunct="1">
+    <a:lvl1pPr marL="0" algn="l" defTabSz="457200" rtl="0" eaLnBrk="1" latinLnBrk="0" hangingPunct="1">
       <a:defRPr sz="1800" kern="1200">
         <a:solidFill>
           <a:schemeClr val="tx1"/>
@@ -23,7 +24,7 @@
         <a:cs typeface="+mn-cs"/>
       </a:defRPr>
     </a:lvl1pPr>
-    <a:lvl2pPr marL="457200" algn="l" defTabSz="914400" rtl="0" eaLnBrk="1" latinLnBrk="0" hangingPunct="1">
+    <a:lvl2pPr marL="457200" algn="l" defTabSz="457200" rtl="0" eaLnBrk="1" latinLnBrk="0" hangingPunct="1">
       <a:defRPr sz="1800" kern="1200">
         <a:solidFill>
           <a:schemeClr val="tx1"/>
@@ -33,7 +34,7 @@
         <a:cs typeface="+mn-cs"/>
       </a:defRPr>
     </a:lvl2pPr>
-    <a:lvl3pPr marL="914400" algn="l" defTabSz="914400" rtl="0" eaLnBrk="1" latinLnBrk="0" hangingPunct="1">
+    <a:lvl3pPr marL="914400" algn="l" defTabSz="457200" rtl="0" eaLnBrk="1" latinLnBrk="0" hangingPunct="1">
       <a:defRPr sz="1800" kern="1200">
         <a:solidFill>
           <a:schemeClr val="tx1"/>
@@ -43,7 +44,7 @@
         <a:cs typeface="+mn-cs"/>
       </a:defRPr>
     </a:lvl3pPr>
-    <a:lvl4pPr marL="1371600" algn="l" defTabSz="914400" rtl="0" eaLnBrk="1" latinLnBrk="0" hangingPunct="1">
+    <a:lvl4pPr marL="1371600" algn="l" defTabSz="457200" rtl="0" eaLnBrk="1" latinLnBrk="0" hangingPunct="1">
       <a:defRPr sz="1800" kern="1200">
         <a:solidFill>
           <a:schemeClr val="tx1"/>
@@ -53,7 +54,7 @@
         <a:cs typeface="+mn-cs"/>
       </a:defRPr>
     </a:lvl4pPr>
-    <a:lvl5pPr marL="1828800" algn="l" defTabSz="914400" rtl="0" eaLnBrk="1" latinLnBrk="0" hangingPunct="1">
+    <a:lvl5pPr marL="1828800" algn="l" defTabSz="457200" rtl="0" eaLnBrk="1" latinLnBrk="0" hangingPunct="1">
       <a:defRPr sz="1800" kern="1200">
         <a:solidFill>
           <a:schemeClr val="tx1"/>
@@ -63,7 +64,7 @@
         <a:cs typeface="+mn-cs"/>
       </a:defRPr>
     </a:lvl5pPr>
-    <a:lvl6pPr marL="2286000" algn="l" defTabSz="914400" rtl="0" eaLnBrk="1" latinLnBrk="0" hangingPunct="1">
+    <a:lvl6pPr marL="2286000" algn="l" defTabSz="457200" rtl="0" eaLnBrk="1" latinLnBrk="0" hangingPunct="1">
       <a:defRPr sz="1800" kern="1200">
         <a:solidFill>
           <a:schemeClr val="tx1"/>
@@ -73,7 +74,7 @@
         <a:cs typeface="+mn-cs"/>
       </a:defRPr>
     </a:lvl6pPr>
-    <a:lvl7pPr marL="2743200" algn="l" defTabSz="914400" rtl="0" eaLnBrk="1" latinLnBrk="0" hangingPunct="1">
+    <a:lvl7pPr marL="2743200" algn="l" defTabSz="457200" rtl="0" eaLnBrk="1" latinLnBrk="0" hangingPunct="1">
       <a:defRPr sz="1800" kern="1200">
         <a:solidFill>
           <a:schemeClr val="tx1"/>
@@ -83,7 +84,7 @@
         <a:cs typeface="+mn-cs"/>
       </a:defRPr>
     </a:lvl7pPr>
-    <a:lvl8pPr marL="3200400" algn="l" defTabSz="914400" rtl="0" eaLnBrk="1" latinLnBrk="0" hangingPunct="1">
+    <a:lvl8pPr marL="3200400" algn="l" defTabSz="457200" rtl="0" eaLnBrk="1" latinLnBrk="0" hangingPunct="1">
       <a:defRPr sz="1800" kern="1200">
         <a:solidFill>
           <a:schemeClr val="tx1"/>
@@ -93,7 +94,7 @@
         <a:cs typeface="+mn-cs"/>
       </a:defRPr>
     </a:lvl8pPr>
-    <a:lvl9pPr marL="3657600" algn="l" defTabSz="914400" rtl="0" eaLnBrk="1" latinLnBrk="0" hangingPunct="1">
+    <a:lvl9pPr marL="3657600" algn="l" defTabSz="457200" rtl="0" eaLnBrk="1" latinLnBrk="0" hangingPunct="1">
       <a:defRPr sz="1800" kern="1200">
         <a:solidFill>
           <a:schemeClr val="tx1"/>
@@ -104,6 +105,11 @@
       </a:defRPr>
     </a:lvl9pPr>
   </p:defaultTextStyle>
+  <p:extLst>
+    <p:ext uri="{EFAFB233-063F-42B5-8137-9DF3F51BA10A}">
+      <p15:sldGuideLst xmlns:p15="http://schemas.microsoft.com/office/powerpoint/2012/main"/>
+    </p:ext>
+  </p:extLst>
 </p:presentation>
 </file>
 
@@ -126,13 +132,7 @@
       </p:grpSpPr>
       <p:sp>
         <p:nvSpPr>
-          <p:cNvPr id="2" name="Title 1">
-            <a:extLst>
-              <a:ext uri="{FF2B5EF4-FFF2-40B4-BE49-F238E27FC236}">
-                <a16:creationId xmlns:a16="http://schemas.microsoft.com/office/drawing/2014/main" id="{3031D994-A77D-1039-75A5-7856F6014DAD}"/>
-              </a:ext>
-            </a:extLst>
-          </p:cNvPr>
+          <p:cNvPr id="2" name="Title 1"/>
           <p:cNvSpPr>
             <a:spLocks noGrp="1"/>
           </p:cNvSpPr>
@@ -142,8 +142,8 @@
         </p:nvSpPr>
         <p:spPr>
           <a:xfrm>
-            <a:off x="1524000" y="1122363"/>
-            <a:ext cx="9144000" cy="2387600"/>
+            <a:off x="685800" y="1122363"/>
+            <a:ext cx="7772400" cy="2387600"/>
           </a:xfrm>
         </p:spPr>
         <p:txBody>
@@ -158,18 +158,13 @@
               <a:rPr lang="en-US"/>
               <a:t>Click to edit Master title style</a:t>
             </a:r>
-          </a:p>
-        </p:txBody>
-      </p:sp>
-      <p:sp>
-        <p:nvSpPr>
-          <p:cNvPr id="3" name="Subtitle 2">
-            <a:extLst>
-              <a:ext uri="{FF2B5EF4-FFF2-40B4-BE49-F238E27FC236}">
-                <a16:creationId xmlns:a16="http://schemas.microsoft.com/office/drawing/2014/main" id="{726A7D44-71DF-D2A9-E989-F443B8BAEC05}"/>
-              </a:ext>
-            </a:extLst>
-          </p:cNvPr>
+            <a:endParaRPr lang="en-US" dirty="0"/>
+          </a:p>
+        </p:txBody>
+      </p:sp>
+      <p:sp>
+        <p:nvSpPr>
+          <p:cNvPr id="3" name="Subtitle 2"/>
           <p:cNvSpPr>
             <a:spLocks noGrp="1"/>
           </p:cNvSpPr>
@@ -179,8 +174,8 @@
         </p:nvSpPr>
         <p:spPr>
           <a:xfrm>
-            <a:off x="1524000" y="3602038"/>
-            <a:ext cx="9144000" cy="1655762"/>
+            <a:off x="1143000" y="3602038"/>
+            <a:ext cx="6858000" cy="1655762"/>
           </a:xfrm>
         </p:spPr>
         <p:txBody>
@@ -228,18 +223,13 @@
               <a:rPr lang="en-US"/>
               <a:t>Click to edit Master subtitle style</a:t>
             </a:r>
-          </a:p>
-        </p:txBody>
-      </p:sp>
-      <p:sp>
-        <p:nvSpPr>
-          <p:cNvPr id="4" name="Date Placeholder 3">
-            <a:extLst>
-              <a:ext uri="{FF2B5EF4-FFF2-40B4-BE49-F238E27FC236}">
-                <a16:creationId xmlns:a16="http://schemas.microsoft.com/office/drawing/2014/main" id="{0A033E4D-6E5E-FF11-BAFB-9C5968F0D10E}"/>
-              </a:ext>
-            </a:extLst>
-          </p:cNvPr>
+            <a:endParaRPr lang="en-US" dirty="0"/>
+          </a:p>
+        </p:txBody>
+      </p:sp>
+      <p:sp>
+        <p:nvSpPr>
+          <p:cNvPr id="4" name="Date Placeholder 3"/>
           <p:cNvSpPr>
             <a:spLocks noGrp="1"/>
           </p:cNvSpPr>
@@ -254,7 +244,7 @@
           <a:p>
             <a:fld id="{A9CC02D6-97AE-0D43-90A4-072ED046C1C1}" type="datetimeFigureOut">
               <a:rPr lang="en-US" smtClean="0"/>
-              <a:t>9/14/26</a:t>
+              <a:t>9/30/26</a:t>
             </a:fld>
             <a:endParaRPr lang="en-US"/>
           </a:p>
@@ -262,13 +252,7 @@
       </p:sp>
       <p:sp>
         <p:nvSpPr>
-          <p:cNvPr id="5" name="Footer Placeholder 4">
-            <a:extLst>
-              <a:ext uri="{FF2B5EF4-FFF2-40B4-BE49-F238E27FC236}">
-                <a16:creationId xmlns:a16="http://schemas.microsoft.com/office/drawing/2014/main" id="{6B19E816-1CC5-6474-732B-2CD0D7D6B9C5}"/>
-              </a:ext>
-            </a:extLst>
-          </p:cNvPr>
+          <p:cNvPr id="5" name="Footer Placeholder 4"/>
           <p:cNvSpPr>
             <a:spLocks noGrp="1"/>
           </p:cNvSpPr>
@@ -287,13 +271,7 @@
       </p:sp>
       <p:sp>
         <p:nvSpPr>
-          <p:cNvPr id="6" name="Slide Number Placeholder 5">
-            <a:extLst>
-              <a:ext uri="{FF2B5EF4-FFF2-40B4-BE49-F238E27FC236}">
-                <a16:creationId xmlns:a16="http://schemas.microsoft.com/office/drawing/2014/main" id="{418F0FD4-36DB-B25F-17AA-F3350EB88E8A}"/>
-              </a:ext>
-            </a:extLst>
-          </p:cNvPr>
+          <p:cNvPr id="6" name="Slide Number Placeholder 5"/>
           <p:cNvSpPr>
             <a:spLocks noGrp="1"/>
           </p:cNvSpPr>
@@ -317,7 +295,7 @@
     </p:spTree>
     <p:extLst>
       <p:ext uri="{BB962C8B-B14F-4D97-AF65-F5344CB8AC3E}">
-        <p14:creationId xmlns:p14="http://schemas.microsoft.com/office/powerpoint/2010/main" val="3750596238"/>
+        <p14:creationId xmlns:p14="http://schemas.microsoft.com/office/powerpoint/2010/main" val="3031806833"/>
       </p:ext>
     </p:extLst>
   </p:cSld>
@@ -346,13 +324,7 @@
       </p:grpSpPr>
       <p:sp>
         <p:nvSpPr>
-          <p:cNvPr id="2" name="Title 1">
-            <a:extLst>
-              <a:ext uri="{FF2B5EF4-FFF2-40B4-BE49-F238E27FC236}">
-                <a16:creationId xmlns:a16="http://schemas.microsoft.com/office/drawing/2014/main" id="{F7E61BAE-EBB0-6FC4-103C-9B664267A947}"/>
-              </a:ext>
-            </a:extLst>
-          </p:cNvPr>
+          <p:cNvPr id="2" name="Title 1"/>
           <p:cNvSpPr>
             <a:spLocks noGrp="1"/>
           </p:cNvSpPr>
@@ -369,18 +341,13 @@
               <a:rPr lang="en-US"/>
               <a:t>Click to edit Master title style</a:t>
             </a:r>
-          </a:p>
-        </p:txBody>
-      </p:sp>
-      <p:sp>
-        <p:nvSpPr>
-          <p:cNvPr id="3" name="Vertical Text Placeholder 2">
-            <a:extLst>
-              <a:ext uri="{FF2B5EF4-FFF2-40B4-BE49-F238E27FC236}">
-                <a16:creationId xmlns:a16="http://schemas.microsoft.com/office/drawing/2014/main" id="{370D66D5-B6E0-2571-8F24-9A0A03A65FE6}"/>
-              </a:ext>
-            </a:extLst>
-          </p:cNvPr>
+            <a:endParaRPr lang="en-US" dirty="0"/>
+          </a:p>
+        </p:txBody>
+      </p:sp>
+      <p:sp>
+        <p:nvSpPr>
+          <p:cNvPr id="3" name="Vertical Text Placeholder 2"/>
           <p:cNvSpPr>
             <a:spLocks noGrp="1"/>
           </p:cNvSpPr>
@@ -426,18 +393,13 @@
               <a:rPr lang="en-US"/>
               <a:t>Fifth level</a:t>
             </a:r>
-          </a:p>
-        </p:txBody>
-      </p:sp>
-      <p:sp>
-        <p:nvSpPr>
-          <p:cNvPr id="4" name="Date Placeholder 3">
-            <a:extLst>
-              <a:ext uri="{FF2B5EF4-FFF2-40B4-BE49-F238E27FC236}">
-                <a16:creationId xmlns:a16="http://schemas.microsoft.com/office/drawing/2014/main" id="{1B47626F-FD64-3A08-6704-225C1169590A}"/>
-              </a:ext>
-            </a:extLst>
-          </p:cNvPr>
+            <a:endParaRPr lang="en-US" dirty="0"/>
+          </a:p>
+        </p:txBody>
+      </p:sp>
+      <p:sp>
+        <p:nvSpPr>
+          <p:cNvPr id="4" name="Date Placeholder 3"/>
           <p:cNvSpPr>
             <a:spLocks noGrp="1"/>
           </p:cNvSpPr>
@@ -452,7 +414,7 @@
           <a:p>
             <a:fld id="{A9CC02D6-97AE-0D43-90A4-072ED046C1C1}" type="datetimeFigureOut">
               <a:rPr lang="en-US" smtClean="0"/>
-              <a:t>9/14/26</a:t>
+              <a:t>9/30/26</a:t>
             </a:fld>
             <a:endParaRPr lang="en-US"/>
           </a:p>
@@ -460,13 +422,7 @@
       </p:sp>
       <p:sp>
         <p:nvSpPr>
-          <p:cNvPr id="5" name="Footer Placeholder 4">
-            <a:extLst>
-              <a:ext uri="{FF2B5EF4-FFF2-40B4-BE49-F238E27FC236}">
-                <a16:creationId xmlns:a16="http://schemas.microsoft.com/office/drawing/2014/main" id="{8DF44202-D2BD-0E90-24A1-3A106B0AFEF2}"/>
-              </a:ext>
-            </a:extLst>
-          </p:cNvPr>
+          <p:cNvPr id="5" name="Footer Placeholder 4"/>
           <p:cNvSpPr>
             <a:spLocks noGrp="1"/>
           </p:cNvSpPr>
@@ -485,13 +441,7 @@
       </p:sp>
       <p:sp>
         <p:nvSpPr>
-          <p:cNvPr id="6" name="Slide Number Placeholder 5">
-            <a:extLst>
-              <a:ext uri="{FF2B5EF4-FFF2-40B4-BE49-F238E27FC236}">
-                <a16:creationId xmlns:a16="http://schemas.microsoft.com/office/drawing/2014/main" id="{DF5F47F8-EA9C-0FB3-F901-3349D17A1E9C}"/>
-              </a:ext>
-            </a:extLst>
-          </p:cNvPr>
+          <p:cNvPr id="6" name="Slide Number Placeholder 5"/>
           <p:cNvSpPr>
             <a:spLocks noGrp="1"/>
           </p:cNvSpPr>
@@ -515,7 +465,7 @@
     </p:spTree>
     <p:extLst>
       <p:ext uri="{BB962C8B-B14F-4D97-AF65-F5344CB8AC3E}">
-        <p14:creationId xmlns:p14="http://schemas.microsoft.com/office/powerpoint/2010/main" val="3555947868"/>
+        <p14:creationId xmlns:p14="http://schemas.microsoft.com/office/powerpoint/2010/main" val="3080750591"/>
       </p:ext>
     </p:extLst>
   </p:cSld>
@@ -544,13 +494,7 @@
       </p:grpSpPr>
       <p:sp>
         <p:nvSpPr>
-          <p:cNvPr id="2" name="Vertical Title 1">
-            <a:extLst>
-              <a:ext uri="{FF2B5EF4-FFF2-40B4-BE49-F238E27FC236}">
-                <a16:creationId xmlns:a16="http://schemas.microsoft.com/office/drawing/2014/main" id="{72CB16C5-2DAC-A753-AAD4-5DFC5FC35614}"/>
-              </a:ext>
-            </a:extLst>
-          </p:cNvPr>
+          <p:cNvPr id="2" name="Vertical Title 1"/>
           <p:cNvSpPr>
             <a:spLocks noGrp="1"/>
           </p:cNvSpPr>
@@ -560,8 +504,8 @@
         </p:nvSpPr>
         <p:spPr>
           <a:xfrm>
-            <a:off x="8724900" y="365125"/>
-            <a:ext cx="2628900" cy="5811838"/>
+            <a:off x="6543675" y="365125"/>
+            <a:ext cx="1971675" cy="5811838"/>
           </a:xfrm>
         </p:spPr>
         <p:txBody>
@@ -572,18 +516,13 @@
               <a:rPr lang="en-US"/>
               <a:t>Click to edit Master title style</a:t>
             </a:r>
-          </a:p>
-        </p:txBody>
-      </p:sp>
-      <p:sp>
-        <p:nvSpPr>
-          <p:cNvPr id="3" name="Vertical Text Placeholder 2">
-            <a:extLst>
-              <a:ext uri="{FF2B5EF4-FFF2-40B4-BE49-F238E27FC236}">
-                <a16:creationId xmlns:a16="http://schemas.microsoft.com/office/drawing/2014/main" id="{6CFE09FF-321C-4060-2434-B96B0BAEC28C}"/>
-              </a:ext>
-            </a:extLst>
-          </p:cNvPr>
+            <a:endParaRPr lang="en-US" dirty="0"/>
+          </a:p>
+        </p:txBody>
+      </p:sp>
+      <p:sp>
+        <p:nvSpPr>
+          <p:cNvPr id="3" name="Vertical Text Placeholder 2"/>
           <p:cNvSpPr>
             <a:spLocks noGrp="1"/>
           </p:cNvSpPr>
@@ -593,8 +532,8 @@
         </p:nvSpPr>
         <p:spPr>
           <a:xfrm>
-            <a:off x="838200" y="365125"/>
-            <a:ext cx="7734300" cy="5811838"/>
+            <a:off x="628650" y="365125"/>
+            <a:ext cx="5800725" cy="5811838"/>
           </a:xfrm>
         </p:spPr>
         <p:txBody>
@@ -634,18 +573,13 @@
               <a:rPr lang="en-US"/>
               <a:t>Fifth level</a:t>
             </a:r>
-          </a:p>
-        </p:txBody>
-      </p:sp>
-      <p:sp>
-        <p:nvSpPr>
-          <p:cNvPr id="4" name="Date Placeholder 3">
-            <a:extLst>
-              <a:ext uri="{FF2B5EF4-FFF2-40B4-BE49-F238E27FC236}">
-                <a16:creationId xmlns:a16="http://schemas.microsoft.com/office/drawing/2014/main" id="{C68DE7EB-28BD-7A18-F188-5FC125AC49DA}"/>
-              </a:ext>
-            </a:extLst>
-          </p:cNvPr>
+            <a:endParaRPr lang="en-US" dirty="0"/>
+          </a:p>
+        </p:txBody>
+      </p:sp>
+      <p:sp>
+        <p:nvSpPr>
+          <p:cNvPr id="4" name="Date Placeholder 3"/>
           <p:cNvSpPr>
             <a:spLocks noGrp="1"/>
           </p:cNvSpPr>
@@ -660,7 +594,7 @@
           <a:p>
             <a:fld id="{A9CC02D6-97AE-0D43-90A4-072ED046C1C1}" type="datetimeFigureOut">
               <a:rPr lang="en-US" smtClean="0"/>
-              <a:t>9/14/26</a:t>
+              <a:t>9/30/26</a:t>
             </a:fld>
             <a:endParaRPr lang="en-US"/>
           </a:p>
@@ -668,13 +602,7 @@
       </p:sp>
       <p:sp>
         <p:nvSpPr>
-          <p:cNvPr id="5" name="Footer Placeholder 4">
-            <a:extLst>
-              <a:ext uri="{FF2B5EF4-FFF2-40B4-BE49-F238E27FC236}">
-                <a16:creationId xmlns:a16="http://schemas.microsoft.com/office/drawing/2014/main" id="{C3800D07-366B-89BF-D4B0-39F82C5835C8}"/>
-              </a:ext>
-            </a:extLst>
-          </p:cNvPr>
+          <p:cNvPr id="5" name="Footer Placeholder 4"/>
           <p:cNvSpPr>
             <a:spLocks noGrp="1"/>
           </p:cNvSpPr>
@@ -693,13 +621,7 @@
       </p:sp>
       <p:sp>
         <p:nvSpPr>
-          <p:cNvPr id="6" name="Slide Number Placeholder 5">
-            <a:extLst>
-              <a:ext uri="{FF2B5EF4-FFF2-40B4-BE49-F238E27FC236}">
-                <a16:creationId xmlns:a16="http://schemas.microsoft.com/office/drawing/2014/main" id="{2BDF223D-5C9E-3049-2FBC-F29550DB5A9B}"/>
-              </a:ext>
-            </a:extLst>
-          </p:cNvPr>
+          <p:cNvPr id="6" name="Slide Number Placeholder 5"/>
           <p:cNvSpPr>
             <a:spLocks noGrp="1"/>
           </p:cNvSpPr>
@@ -723,7 +645,7 @@
     </p:spTree>
     <p:extLst>
       <p:ext uri="{BB962C8B-B14F-4D97-AF65-F5344CB8AC3E}">
-        <p14:creationId xmlns:p14="http://schemas.microsoft.com/office/powerpoint/2010/main" val="2107536827"/>
+        <p14:creationId xmlns:p14="http://schemas.microsoft.com/office/powerpoint/2010/main" val="1533264483"/>
       </p:ext>
     </p:extLst>
   </p:cSld>
@@ -752,13 +674,7 @@
       </p:grpSpPr>
       <p:sp>
         <p:nvSpPr>
-          <p:cNvPr id="2" name="Title 1">
-            <a:extLst>
-              <a:ext uri="{FF2B5EF4-FFF2-40B4-BE49-F238E27FC236}">
-                <a16:creationId xmlns:a16="http://schemas.microsoft.com/office/drawing/2014/main" id="{19E9ED4E-9668-FC56-CD7C-98BA542D0E0F}"/>
-              </a:ext>
-            </a:extLst>
-          </p:cNvPr>
+          <p:cNvPr id="2" name="Title 1"/>
           <p:cNvSpPr>
             <a:spLocks noGrp="1"/>
           </p:cNvSpPr>
@@ -775,18 +691,13 @@
               <a:rPr lang="en-US"/>
               <a:t>Click to edit Master title style</a:t>
             </a:r>
-          </a:p>
-        </p:txBody>
-      </p:sp>
-      <p:sp>
-        <p:nvSpPr>
-          <p:cNvPr id="3" name="Content Placeholder 2">
-            <a:extLst>
-              <a:ext uri="{FF2B5EF4-FFF2-40B4-BE49-F238E27FC236}">
-                <a16:creationId xmlns:a16="http://schemas.microsoft.com/office/drawing/2014/main" id="{9E39D373-99C1-0969-1640-9CE5453FDCE4}"/>
-              </a:ext>
-            </a:extLst>
-          </p:cNvPr>
+            <a:endParaRPr lang="en-US" dirty="0"/>
+          </a:p>
+        </p:txBody>
+      </p:sp>
+      <p:sp>
+        <p:nvSpPr>
+          <p:cNvPr id="3" name="Content Placeholder 2"/>
           <p:cNvSpPr>
             <a:spLocks noGrp="1"/>
           </p:cNvSpPr>
@@ -832,18 +743,13 @@
               <a:rPr lang="en-US"/>
               <a:t>Fifth level</a:t>
             </a:r>
-          </a:p>
-        </p:txBody>
-      </p:sp>
-      <p:sp>
-        <p:nvSpPr>
-          <p:cNvPr id="4" name="Date Placeholder 3">
-            <a:extLst>
-              <a:ext uri="{FF2B5EF4-FFF2-40B4-BE49-F238E27FC236}">
-                <a16:creationId xmlns:a16="http://schemas.microsoft.com/office/drawing/2014/main" id="{E6A2CDEC-4D0E-84E8-20E1-0A298B934865}"/>
-              </a:ext>
-            </a:extLst>
-          </p:cNvPr>
+            <a:endParaRPr lang="en-US" dirty="0"/>
+          </a:p>
+        </p:txBody>
+      </p:sp>
+      <p:sp>
+        <p:nvSpPr>
+          <p:cNvPr id="4" name="Date Placeholder 3"/>
           <p:cNvSpPr>
             <a:spLocks noGrp="1"/>
           </p:cNvSpPr>
@@ -858,7 +764,7 @@
           <a:p>
             <a:fld id="{A9CC02D6-97AE-0D43-90A4-072ED046C1C1}" type="datetimeFigureOut">
               <a:rPr lang="en-US" smtClean="0"/>
-              <a:t>9/14/26</a:t>
+              <a:t>9/30/26</a:t>
             </a:fld>
             <a:endParaRPr lang="en-US"/>
           </a:p>
@@ -866,13 +772,7 @@
       </p:sp>
       <p:sp>
         <p:nvSpPr>
-          <p:cNvPr id="5" name="Footer Placeholder 4">
-            <a:extLst>
-              <a:ext uri="{FF2B5EF4-FFF2-40B4-BE49-F238E27FC236}">
-                <a16:creationId xmlns:a16="http://schemas.microsoft.com/office/drawing/2014/main" id="{BC5642B1-BE13-DE14-97E3-BC4A2603998C}"/>
-              </a:ext>
-            </a:extLst>
-          </p:cNvPr>
+          <p:cNvPr id="5" name="Footer Placeholder 4"/>
           <p:cNvSpPr>
             <a:spLocks noGrp="1"/>
           </p:cNvSpPr>
@@ -891,13 +791,7 @@
       </p:sp>
       <p:sp>
         <p:nvSpPr>
-          <p:cNvPr id="6" name="Slide Number Placeholder 5">
-            <a:extLst>
-              <a:ext uri="{FF2B5EF4-FFF2-40B4-BE49-F238E27FC236}">
-                <a16:creationId xmlns:a16="http://schemas.microsoft.com/office/drawing/2014/main" id="{04D3B985-3408-D060-C66B-5409E673E03E}"/>
-              </a:ext>
-            </a:extLst>
-          </p:cNvPr>
+          <p:cNvPr id="6" name="Slide Number Placeholder 5"/>
           <p:cNvSpPr>
             <a:spLocks noGrp="1"/>
           </p:cNvSpPr>
@@ -921,7 +815,7 @@
     </p:spTree>
     <p:extLst>
       <p:ext uri="{BB962C8B-B14F-4D97-AF65-F5344CB8AC3E}">
-        <p14:creationId xmlns:p14="http://schemas.microsoft.com/office/powerpoint/2010/main" val="2218508422"/>
+        <p14:creationId xmlns:p14="http://schemas.microsoft.com/office/powerpoint/2010/main" val="2670291776"/>
       </p:ext>
     </p:extLst>
   </p:cSld>
@@ -950,13 +844,7 @@
       </p:grpSpPr>
       <p:sp>
         <p:nvSpPr>
-          <p:cNvPr id="2" name="Title 1">
-            <a:extLst>
-              <a:ext uri="{FF2B5EF4-FFF2-40B4-BE49-F238E27FC236}">
-                <a16:creationId xmlns:a16="http://schemas.microsoft.com/office/drawing/2014/main" id="{D77F74E2-6D16-9F01-3D3E-825154B3FD98}"/>
-              </a:ext>
-            </a:extLst>
-          </p:cNvPr>
+          <p:cNvPr id="2" name="Title 1"/>
           <p:cNvSpPr>
             <a:spLocks noGrp="1"/>
           </p:cNvSpPr>
@@ -966,8 +854,8 @@
         </p:nvSpPr>
         <p:spPr>
           <a:xfrm>
-            <a:off x="831850" y="1709738"/>
-            <a:ext cx="10515600" cy="2852737"/>
+            <a:off x="623888" y="1709739"/>
+            <a:ext cx="7886700" cy="2852737"/>
           </a:xfrm>
         </p:spPr>
         <p:txBody>
@@ -982,18 +870,13 @@
               <a:rPr lang="en-US"/>
               <a:t>Click to edit Master title style</a:t>
             </a:r>
-          </a:p>
-        </p:txBody>
-      </p:sp>
-      <p:sp>
-        <p:nvSpPr>
-          <p:cNvPr id="3" name="Text Placeholder 2">
-            <a:extLst>
-              <a:ext uri="{FF2B5EF4-FFF2-40B4-BE49-F238E27FC236}">
-                <a16:creationId xmlns:a16="http://schemas.microsoft.com/office/drawing/2014/main" id="{B1C50B73-0EFF-B656-D974-4A94B911904A}"/>
-              </a:ext>
-            </a:extLst>
-          </p:cNvPr>
+            <a:endParaRPr lang="en-US" dirty="0"/>
+          </a:p>
+        </p:txBody>
+      </p:sp>
+      <p:sp>
+        <p:nvSpPr>
+          <p:cNvPr id="3" name="Text Placeholder 2"/>
           <p:cNvSpPr>
             <a:spLocks noGrp="1"/>
           </p:cNvSpPr>
@@ -1003,8 +886,8 @@
         </p:nvSpPr>
         <p:spPr>
           <a:xfrm>
-            <a:off x="831850" y="4589463"/>
-            <a:ext cx="10515600" cy="1500187"/>
+            <a:off x="623888" y="4589464"/>
+            <a:ext cx="7886700" cy="1500187"/>
           </a:xfrm>
         </p:spPr>
         <p:txBody>
@@ -1112,13 +995,7 @@
       </p:sp>
       <p:sp>
         <p:nvSpPr>
-          <p:cNvPr id="4" name="Date Placeholder 3">
-            <a:extLst>
-              <a:ext uri="{FF2B5EF4-FFF2-40B4-BE49-F238E27FC236}">
-                <a16:creationId xmlns:a16="http://schemas.microsoft.com/office/drawing/2014/main" id="{75BBD0B6-AA78-EFF0-EF96-95B0A47FF492}"/>
-              </a:ext>
-            </a:extLst>
-          </p:cNvPr>
+          <p:cNvPr id="4" name="Date Placeholder 3"/>
           <p:cNvSpPr>
             <a:spLocks noGrp="1"/>
           </p:cNvSpPr>
@@ -1133,7 +1010,7 @@
           <a:p>
             <a:fld id="{A9CC02D6-97AE-0D43-90A4-072ED046C1C1}" type="datetimeFigureOut">
               <a:rPr lang="en-US" smtClean="0"/>
-              <a:t>9/14/26</a:t>
+              <a:t>9/30/26</a:t>
             </a:fld>
             <a:endParaRPr lang="en-US"/>
           </a:p>
@@ -1141,13 +1018,7 @@
       </p:sp>
       <p:sp>
         <p:nvSpPr>
-          <p:cNvPr id="5" name="Footer Placeholder 4">
-            <a:extLst>
-              <a:ext uri="{FF2B5EF4-FFF2-40B4-BE49-F238E27FC236}">
-                <a16:creationId xmlns:a16="http://schemas.microsoft.com/office/drawing/2014/main" id="{2FB606F3-4495-D376-C6DC-B9129092E037}"/>
-              </a:ext>
-            </a:extLst>
-          </p:cNvPr>
+          <p:cNvPr id="5" name="Footer Placeholder 4"/>
           <p:cNvSpPr>
             <a:spLocks noGrp="1"/>
           </p:cNvSpPr>
@@ -1166,13 +1037,7 @@
       </p:sp>
       <p:sp>
         <p:nvSpPr>
-          <p:cNvPr id="6" name="Slide Number Placeholder 5">
-            <a:extLst>
-              <a:ext uri="{FF2B5EF4-FFF2-40B4-BE49-F238E27FC236}">
-                <a16:creationId xmlns:a16="http://schemas.microsoft.com/office/drawing/2014/main" id="{293A6D70-CB10-2151-4C78-CB976B0C296E}"/>
-              </a:ext>
-            </a:extLst>
-          </p:cNvPr>
+          <p:cNvPr id="6" name="Slide Number Placeholder 5"/>
           <p:cNvSpPr>
             <a:spLocks noGrp="1"/>
           </p:cNvSpPr>
@@ -1196,7 +1061,7 @@
     </p:spTree>
     <p:extLst>
       <p:ext uri="{BB962C8B-B14F-4D97-AF65-F5344CB8AC3E}">
-        <p14:creationId xmlns:p14="http://schemas.microsoft.com/office/powerpoint/2010/main" val="3187186792"/>
+        <p14:creationId xmlns:p14="http://schemas.microsoft.com/office/powerpoint/2010/main" val="245542236"/>
       </p:ext>
     </p:extLst>
   </p:cSld>
@@ -1225,13 +1090,7 @@
       </p:grpSpPr>
       <p:sp>
         <p:nvSpPr>
-          <p:cNvPr id="2" name="Title 1">
-            <a:extLst>
-              <a:ext uri="{FF2B5EF4-FFF2-40B4-BE49-F238E27FC236}">
-                <a16:creationId xmlns:a16="http://schemas.microsoft.com/office/drawing/2014/main" id="{0C0749FC-60DC-FB43-01A2-202340CF2086}"/>
-              </a:ext>
-            </a:extLst>
-          </p:cNvPr>
+          <p:cNvPr id="2" name="Title 1"/>
           <p:cNvSpPr>
             <a:spLocks noGrp="1"/>
           </p:cNvSpPr>
@@ -1248,18 +1107,13 @@
               <a:rPr lang="en-US"/>
               <a:t>Click to edit Master title style</a:t>
             </a:r>
-          </a:p>
-        </p:txBody>
-      </p:sp>
-      <p:sp>
-        <p:nvSpPr>
-          <p:cNvPr id="3" name="Content Placeholder 2">
-            <a:extLst>
-              <a:ext uri="{FF2B5EF4-FFF2-40B4-BE49-F238E27FC236}">
-                <a16:creationId xmlns:a16="http://schemas.microsoft.com/office/drawing/2014/main" id="{BAFCE61C-4861-2A03-2631-4122832BEFCF}"/>
-              </a:ext>
-            </a:extLst>
-          </p:cNvPr>
+            <a:endParaRPr lang="en-US" dirty="0"/>
+          </a:p>
+        </p:txBody>
+      </p:sp>
+      <p:sp>
+        <p:nvSpPr>
+          <p:cNvPr id="3" name="Content Placeholder 2"/>
           <p:cNvSpPr>
             <a:spLocks noGrp="1"/>
           </p:cNvSpPr>
@@ -1269,8 +1123,8 @@
         </p:nvSpPr>
         <p:spPr>
           <a:xfrm>
-            <a:off x="838200" y="1825625"/>
-            <a:ext cx="5181600" cy="4351338"/>
+            <a:off x="628650" y="1825625"/>
+            <a:ext cx="3886200" cy="4351338"/>
           </a:xfrm>
         </p:spPr>
         <p:txBody>
@@ -1310,18 +1164,13 @@
               <a:rPr lang="en-US"/>
               <a:t>Fifth level</a:t>
             </a:r>
-          </a:p>
-        </p:txBody>
-      </p:sp>
-      <p:sp>
-        <p:nvSpPr>
-          <p:cNvPr id="4" name="Content Placeholder 3">
-            <a:extLst>
-              <a:ext uri="{FF2B5EF4-FFF2-40B4-BE49-F238E27FC236}">
-                <a16:creationId xmlns:a16="http://schemas.microsoft.com/office/drawing/2014/main" id="{6DE16E77-3AA5-FFCE-4B65-00F66C3C054B}"/>
-              </a:ext>
-            </a:extLst>
-          </p:cNvPr>
+            <a:endParaRPr lang="en-US" dirty="0"/>
+          </a:p>
+        </p:txBody>
+      </p:sp>
+      <p:sp>
+        <p:nvSpPr>
+          <p:cNvPr id="4" name="Content Placeholder 3"/>
           <p:cNvSpPr>
             <a:spLocks noGrp="1"/>
           </p:cNvSpPr>
@@ -1331,8 +1180,8 @@
         </p:nvSpPr>
         <p:spPr>
           <a:xfrm>
-            <a:off x="6172200" y="1825625"/>
-            <a:ext cx="5181600" cy="4351338"/>
+            <a:off x="4629150" y="1825625"/>
+            <a:ext cx="3886200" cy="4351338"/>
           </a:xfrm>
         </p:spPr>
         <p:txBody>
@@ -1372,18 +1221,13 @@
               <a:rPr lang="en-US"/>
               <a:t>Fifth level</a:t>
             </a:r>
-          </a:p>
-        </p:txBody>
-      </p:sp>
-      <p:sp>
-        <p:nvSpPr>
-          <p:cNvPr id="5" name="Date Placeholder 4">
-            <a:extLst>
-              <a:ext uri="{FF2B5EF4-FFF2-40B4-BE49-F238E27FC236}">
-                <a16:creationId xmlns:a16="http://schemas.microsoft.com/office/drawing/2014/main" id="{F06FDDBB-2BEC-EF86-3A4D-3FAF9745D067}"/>
-              </a:ext>
-            </a:extLst>
-          </p:cNvPr>
+            <a:endParaRPr lang="en-US" dirty="0"/>
+          </a:p>
+        </p:txBody>
+      </p:sp>
+      <p:sp>
+        <p:nvSpPr>
+          <p:cNvPr id="5" name="Date Placeholder 4"/>
           <p:cNvSpPr>
             <a:spLocks noGrp="1"/>
           </p:cNvSpPr>
@@ -1398,7 +1242,7 @@
           <a:p>
             <a:fld id="{A9CC02D6-97AE-0D43-90A4-072ED046C1C1}" type="datetimeFigureOut">
               <a:rPr lang="en-US" smtClean="0"/>
-              <a:t>9/14/26</a:t>
+              <a:t>9/30/26</a:t>
             </a:fld>
             <a:endParaRPr lang="en-US"/>
           </a:p>
@@ -1406,13 +1250,7 @@
       </p:sp>
       <p:sp>
         <p:nvSpPr>
-          <p:cNvPr id="6" name="Footer Placeholder 5">
-            <a:extLst>
-              <a:ext uri="{FF2B5EF4-FFF2-40B4-BE49-F238E27FC236}">
-                <a16:creationId xmlns:a16="http://schemas.microsoft.com/office/drawing/2014/main" id="{01019297-8DAA-DE4B-8183-BA6D1E49696D}"/>
-              </a:ext>
-            </a:extLst>
-          </p:cNvPr>
+          <p:cNvPr id="6" name="Footer Placeholder 5"/>
           <p:cNvSpPr>
             <a:spLocks noGrp="1"/>
           </p:cNvSpPr>
@@ -1431,13 +1269,7 @@
       </p:sp>
       <p:sp>
         <p:nvSpPr>
-          <p:cNvPr id="7" name="Slide Number Placeholder 6">
-            <a:extLst>
-              <a:ext uri="{FF2B5EF4-FFF2-40B4-BE49-F238E27FC236}">
-                <a16:creationId xmlns:a16="http://schemas.microsoft.com/office/drawing/2014/main" id="{0418412A-64AE-B6BF-8470-E3B89BB421EE}"/>
-              </a:ext>
-            </a:extLst>
-          </p:cNvPr>
+          <p:cNvPr id="7" name="Slide Number Placeholder 6"/>
           <p:cNvSpPr>
             <a:spLocks noGrp="1"/>
           </p:cNvSpPr>
@@ -1461,7 +1293,7 @@
     </p:spTree>
     <p:extLst>
       <p:ext uri="{BB962C8B-B14F-4D97-AF65-F5344CB8AC3E}">
-        <p14:creationId xmlns:p14="http://schemas.microsoft.com/office/powerpoint/2010/main" val="1542710979"/>
+        <p14:creationId xmlns:p14="http://schemas.microsoft.com/office/powerpoint/2010/main" val="3497030983"/>
       </p:ext>
     </p:extLst>
   </p:cSld>
@@ -1490,13 +1322,7 @@
       </p:grpSpPr>
       <p:sp>
         <p:nvSpPr>
-          <p:cNvPr id="2" name="Title 1">
-            <a:extLst>
-              <a:ext uri="{FF2B5EF4-FFF2-40B4-BE49-F238E27FC236}">
-                <a16:creationId xmlns:a16="http://schemas.microsoft.com/office/drawing/2014/main" id="{FF17C3DA-3A50-0879-FC02-7C98ACE78E01}"/>
-              </a:ext>
-            </a:extLst>
-          </p:cNvPr>
+          <p:cNvPr id="2" name="Title 1"/>
           <p:cNvSpPr>
             <a:spLocks noGrp="1"/>
           </p:cNvSpPr>
@@ -1506,8 +1332,8 @@
         </p:nvSpPr>
         <p:spPr>
           <a:xfrm>
-            <a:off x="839788" y="365125"/>
-            <a:ext cx="10515600" cy="1325563"/>
+            <a:off x="629841" y="365126"/>
+            <a:ext cx="7886700" cy="1325563"/>
           </a:xfrm>
         </p:spPr>
         <p:txBody>
@@ -1518,18 +1344,13 @@
               <a:rPr lang="en-US"/>
               <a:t>Click to edit Master title style</a:t>
             </a:r>
-          </a:p>
-        </p:txBody>
-      </p:sp>
-      <p:sp>
-        <p:nvSpPr>
-          <p:cNvPr id="3" name="Text Placeholder 2">
-            <a:extLst>
-              <a:ext uri="{FF2B5EF4-FFF2-40B4-BE49-F238E27FC236}">
-                <a16:creationId xmlns:a16="http://schemas.microsoft.com/office/drawing/2014/main" id="{8EDC4E1E-50FB-31BD-DF44-858749AFB747}"/>
-              </a:ext>
-            </a:extLst>
-          </p:cNvPr>
+            <a:endParaRPr lang="en-US" dirty="0"/>
+          </a:p>
+        </p:txBody>
+      </p:sp>
+      <p:sp>
+        <p:nvSpPr>
+          <p:cNvPr id="3" name="Text Placeholder 2"/>
           <p:cNvSpPr>
             <a:spLocks noGrp="1"/>
           </p:cNvSpPr>
@@ -1539,8 +1360,8 @@
         </p:nvSpPr>
         <p:spPr>
           <a:xfrm>
-            <a:off x="839788" y="1681163"/>
-            <a:ext cx="5157787" cy="823912"/>
+            <a:off x="629842" y="1681163"/>
+            <a:ext cx="3868340" cy="823912"/>
           </a:xfrm>
         </p:spPr>
         <p:txBody>
@@ -1594,13 +1415,7 @@
       </p:sp>
       <p:sp>
         <p:nvSpPr>
-          <p:cNvPr id="4" name="Content Placeholder 3">
-            <a:extLst>
-              <a:ext uri="{FF2B5EF4-FFF2-40B4-BE49-F238E27FC236}">
-                <a16:creationId xmlns:a16="http://schemas.microsoft.com/office/drawing/2014/main" id="{C3245A81-816B-51F1-E289-ED892C140A98}"/>
-              </a:ext>
-            </a:extLst>
-          </p:cNvPr>
+          <p:cNvPr id="4" name="Content Placeholder 3"/>
           <p:cNvSpPr>
             <a:spLocks noGrp="1"/>
           </p:cNvSpPr>
@@ -1610,8 +1425,8 @@
         </p:nvSpPr>
         <p:spPr>
           <a:xfrm>
-            <a:off x="839788" y="2505075"/>
-            <a:ext cx="5157787" cy="3684588"/>
+            <a:off x="629842" y="2505075"/>
+            <a:ext cx="3868340" cy="3684588"/>
           </a:xfrm>
         </p:spPr>
         <p:txBody>
@@ -1651,18 +1466,13 @@
               <a:rPr lang="en-US"/>
               <a:t>Fifth level</a:t>
             </a:r>
-          </a:p>
-        </p:txBody>
-      </p:sp>
-      <p:sp>
-        <p:nvSpPr>
-          <p:cNvPr id="5" name="Text Placeholder 4">
-            <a:extLst>
-              <a:ext uri="{FF2B5EF4-FFF2-40B4-BE49-F238E27FC236}">
-                <a16:creationId xmlns:a16="http://schemas.microsoft.com/office/drawing/2014/main" id="{FB9ED242-0111-E717-CD83-F4205260E11D}"/>
-              </a:ext>
-            </a:extLst>
-          </p:cNvPr>
+            <a:endParaRPr lang="en-US" dirty="0"/>
+          </a:p>
+        </p:txBody>
+      </p:sp>
+      <p:sp>
+        <p:nvSpPr>
+          <p:cNvPr id="5" name="Text Placeholder 4"/>
           <p:cNvSpPr>
             <a:spLocks noGrp="1"/>
           </p:cNvSpPr>
@@ -1672,8 +1482,8 @@
         </p:nvSpPr>
         <p:spPr>
           <a:xfrm>
-            <a:off x="6172200" y="1681163"/>
-            <a:ext cx="5183188" cy="823912"/>
+            <a:off x="4629150" y="1681163"/>
+            <a:ext cx="3887391" cy="823912"/>
           </a:xfrm>
         </p:spPr>
         <p:txBody>
@@ -1727,13 +1537,7 @@
       </p:sp>
       <p:sp>
         <p:nvSpPr>
-          <p:cNvPr id="6" name="Content Placeholder 5">
-            <a:extLst>
-              <a:ext uri="{FF2B5EF4-FFF2-40B4-BE49-F238E27FC236}">
-                <a16:creationId xmlns:a16="http://schemas.microsoft.com/office/drawing/2014/main" id="{86739AA8-6321-526A-E09B-1181EB656FE8}"/>
-              </a:ext>
-            </a:extLst>
-          </p:cNvPr>
+          <p:cNvPr id="6" name="Content Placeholder 5"/>
           <p:cNvSpPr>
             <a:spLocks noGrp="1"/>
           </p:cNvSpPr>
@@ -1743,8 +1547,8 @@
         </p:nvSpPr>
         <p:spPr>
           <a:xfrm>
-            <a:off x="6172200" y="2505075"/>
-            <a:ext cx="5183188" cy="3684588"/>
+            <a:off x="4629150" y="2505075"/>
+            <a:ext cx="3887391" cy="3684588"/>
           </a:xfrm>
         </p:spPr>
         <p:txBody>
@@ -1784,18 +1588,13 @@
               <a:rPr lang="en-US"/>
               <a:t>Fifth level</a:t>
             </a:r>
-          </a:p>
-        </p:txBody>
-      </p:sp>
-      <p:sp>
-        <p:nvSpPr>
-          <p:cNvPr id="7" name="Date Placeholder 6">
-            <a:extLst>
-              <a:ext uri="{FF2B5EF4-FFF2-40B4-BE49-F238E27FC236}">
-                <a16:creationId xmlns:a16="http://schemas.microsoft.com/office/drawing/2014/main" id="{425F62F4-EE7F-18AE-9800-F3A687ACEB5A}"/>
-              </a:ext>
-            </a:extLst>
-          </p:cNvPr>
+            <a:endParaRPr lang="en-US" dirty="0"/>
+          </a:p>
+        </p:txBody>
+      </p:sp>
+      <p:sp>
+        <p:nvSpPr>
+          <p:cNvPr id="7" name="Date Placeholder 6"/>
           <p:cNvSpPr>
             <a:spLocks noGrp="1"/>
           </p:cNvSpPr>
@@ -1810,7 +1609,7 @@
           <a:p>
             <a:fld id="{A9CC02D6-97AE-0D43-90A4-072ED046C1C1}" type="datetimeFigureOut">
               <a:rPr lang="en-US" smtClean="0"/>
-              <a:t>9/14/26</a:t>
+              <a:t>9/30/26</a:t>
             </a:fld>
             <a:endParaRPr lang="en-US"/>
           </a:p>
@@ -1818,13 +1617,7 @@
       </p:sp>
       <p:sp>
         <p:nvSpPr>
-          <p:cNvPr id="8" name="Footer Placeholder 7">
-            <a:extLst>
-              <a:ext uri="{FF2B5EF4-FFF2-40B4-BE49-F238E27FC236}">
-                <a16:creationId xmlns:a16="http://schemas.microsoft.com/office/drawing/2014/main" id="{F1116469-1F35-82BE-BB2A-6F7E22698F59}"/>
-              </a:ext>
-            </a:extLst>
-          </p:cNvPr>
+          <p:cNvPr id="8" name="Footer Placeholder 7"/>
           <p:cNvSpPr>
             <a:spLocks noGrp="1"/>
           </p:cNvSpPr>
@@ -1843,13 +1636,7 @@
       </p:sp>
       <p:sp>
         <p:nvSpPr>
-          <p:cNvPr id="9" name="Slide Number Placeholder 8">
-            <a:extLst>
-              <a:ext uri="{FF2B5EF4-FFF2-40B4-BE49-F238E27FC236}">
-                <a16:creationId xmlns:a16="http://schemas.microsoft.com/office/drawing/2014/main" id="{BDEF4540-145D-F893-6E8E-6E939096793E}"/>
-              </a:ext>
-            </a:extLst>
-          </p:cNvPr>
+          <p:cNvPr id="9" name="Slide Number Placeholder 8"/>
           <p:cNvSpPr>
             <a:spLocks noGrp="1"/>
           </p:cNvSpPr>
@@ -1873,7 +1660,7 @@
     </p:spTree>
     <p:extLst>
       <p:ext uri="{BB962C8B-B14F-4D97-AF65-F5344CB8AC3E}">
-        <p14:creationId xmlns:p14="http://schemas.microsoft.com/office/powerpoint/2010/main" val="1894797231"/>
+        <p14:creationId xmlns:p14="http://schemas.microsoft.com/office/powerpoint/2010/main" val="2617511670"/>
       </p:ext>
     </p:extLst>
   </p:cSld>
@@ -1902,13 +1689,7 @@
       </p:grpSpPr>
       <p:sp>
         <p:nvSpPr>
-          <p:cNvPr id="2" name="Title 1">
-            <a:extLst>
-              <a:ext uri="{FF2B5EF4-FFF2-40B4-BE49-F238E27FC236}">
-                <a16:creationId xmlns:a16="http://schemas.microsoft.com/office/drawing/2014/main" id="{4CF6198E-CF11-7994-6FDC-70C46B39185B}"/>
-              </a:ext>
-            </a:extLst>
-          </p:cNvPr>
+          <p:cNvPr id="2" name="Title 1"/>
           <p:cNvSpPr>
             <a:spLocks noGrp="1"/>
           </p:cNvSpPr>
@@ -1925,18 +1706,13 @@
               <a:rPr lang="en-US"/>
               <a:t>Click to edit Master title style</a:t>
             </a:r>
-          </a:p>
-        </p:txBody>
-      </p:sp>
-      <p:sp>
-        <p:nvSpPr>
-          <p:cNvPr id="3" name="Date Placeholder 2">
-            <a:extLst>
-              <a:ext uri="{FF2B5EF4-FFF2-40B4-BE49-F238E27FC236}">
-                <a16:creationId xmlns:a16="http://schemas.microsoft.com/office/drawing/2014/main" id="{1B1D5067-A05D-0D42-2F22-F758D4345782}"/>
-              </a:ext>
-            </a:extLst>
-          </p:cNvPr>
+            <a:endParaRPr lang="en-US" dirty="0"/>
+          </a:p>
+        </p:txBody>
+      </p:sp>
+      <p:sp>
+        <p:nvSpPr>
+          <p:cNvPr id="3" name="Date Placeholder 2"/>
           <p:cNvSpPr>
             <a:spLocks noGrp="1"/>
           </p:cNvSpPr>
@@ -1951,7 +1727,7 @@
           <a:p>
             <a:fld id="{A9CC02D6-97AE-0D43-90A4-072ED046C1C1}" type="datetimeFigureOut">
               <a:rPr lang="en-US" smtClean="0"/>
-              <a:t>9/14/26</a:t>
+              <a:t>9/30/26</a:t>
             </a:fld>
             <a:endParaRPr lang="en-US"/>
           </a:p>
@@ -1959,13 +1735,7 @@
       </p:sp>
       <p:sp>
         <p:nvSpPr>
-          <p:cNvPr id="4" name="Footer Placeholder 3">
-            <a:extLst>
-              <a:ext uri="{FF2B5EF4-FFF2-40B4-BE49-F238E27FC236}">
-                <a16:creationId xmlns:a16="http://schemas.microsoft.com/office/drawing/2014/main" id="{8FD13AEA-D157-2304-FFD5-5EBC735572F3}"/>
-              </a:ext>
-            </a:extLst>
-          </p:cNvPr>
+          <p:cNvPr id="4" name="Footer Placeholder 3"/>
           <p:cNvSpPr>
             <a:spLocks noGrp="1"/>
           </p:cNvSpPr>
@@ -1984,13 +1754,7 @@
       </p:sp>
       <p:sp>
         <p:nvSpPr>
-          <p:cNvPr id="5" name="Slide Number Placeholder 4">
-            <a:extLst>
-              <a:ext uri="{FF2B5EF4-FFF2-40B4-BE49-F238E27FC236}">
-                <a16:creationId xmlns:a16="http://schemas.microsoft.com/office/drawing/2014/main" id="{F476B73E-EBCB-EA60-FE05-07034E82585B}"/>
-              </a:ext>
-            </a:extLst>
-          </p:cNvPr>
+          <p:cNvPr id="5" name="Slide Number Placeholder 4"/>
           <p:cNvSpPr>
             <a:spLocks noGrp="1"/>
           </p:cNvSpPr>
@@ -2014,7 +1778,7 @@
     </p:spTree>
     <p:extLst>
       <p:ext uri="{BB962C8B-B14F-4D97-AF65-F5344CB8AC3E}">
-        <p14:creationId xmlns:p14="http://schemas.microsoft.com/office/powerpoint/2010/main" val="2168753769"/>
+        <p14:creationId xmlns:p14="http://schemas.microsoft.com/office/powerpoint/2010/main" val="689567707"/>
       </p:ext>
     </p:extLst>
   </p:cSld>
@@ -2043,13 +1807,7 @@
       </p:grpSpPr>
       <p:sp>
         <p:nvSpPr>
-          <p:cNvPr id="2" name="Date Placeholder 1">
-            <a:extLst>
-              <a:ext uri="{FF2B5EF4-FFF2-40B4-BE49-F238E27FC236}">
-                <a16:creationId xmlns:a16="http://schemas.microsoft.com/office/drawing/2014/main" id="{60E99CEB-29F9-2687-3676-C9AC51AA7A14}"/>
-              </a:ext>
-            </a:extLst>
-          </p:cNvPr>
+          <p:cNvPr id="2" name="Date Placeholder 1"/>
           <p:cNvSpPr>
             <a:spLocks noGrp="1"/>
           </p:cNvSpPr>
@@ -2064,7 +1822,7 @@
           <a:p>
             <a:fld id="{A9CC02D6-97AE-0D43-90A4-072ED046C1C1}" type="datetimeFigureOut">
               <a:rPr lang="en-US" smtClean="0"/>
-              <a:t>9/14/26</a:t>
+              <a:t>9/30/26</a:t>
             </a:fld>
             <a:endParaRPr lang="en-US"/>
           </a:p>
@@ -2072,13 +1830,7 @@
       </p:sp>
       <p:sp>
         <p:nvSpPr>
-          <p:cNvPr id="3" name="Footer Placeholder 2">
-            <a:extLst>
-              <a:ext uri="{FF2B5EF4-FFF2-40B4-BE49-F238E27FC236}">
-                <a16:creationId xmlns:a16="http://schemas.microsoft.com/office/drawing/2014/main" id="{558F56F7-2CBC-923C-AF11-4C605C5ABEDE}"/>
-              </a:ext>
-            </a:extLst>
-          </p:cNvPr>
+          <p:cNvPr id="3" name="Footer Placeholder 2"/>
           <p:cNvSpPr>
             <a:spLocks noGrp="1"/>
           </p:cNvSpPr>
@@ -2097,13 +1849,7 @@
       </p:sp>
       <p:sp>
         <p:nvSpPr>
-          <p:cNvPr id="4" name="Slide Number Placeholder 3">
-            <a:extLst>
-              <a:ext uri="{FF2B5EF4-FFF2-40B4-BE49-F238E27FC236}">
-                <a16:creationId xmlns:a16="http://schemas.microsoft.com/office/drawing/2014/main" id="{94899D05-8735-FA76-7887-BB00127BAE00}"/>
-              </a:ext>
-            </a:extLst>
-          </p:cNvPr>
+          <p:cNvPr id="4" name="Slide Number Placeholder 3"/>
           <p:cNvSpPr>
             <a:spLocks noGrp="1"/>
           </p:cNvSpPr>
@@ -2127,7 +1873,7 @@
     </p:spTree>
     <p:extLst>
       <p:ext uri="{BB962C8B-B14F-4D97-AF65-F5344CB8AC3E}">
-        <p14:creationId xmlns:p14="http://schemas.microsoft.com/office/powerpoint/2010/main" val="2483960105"/>
+        <p14:creationId xmlns:p14="http://schemas.microsoft.com/office/powerpoint/2010/main" val="3384102872"/>
       </p:ext>
     </p:extLst>
   </p:cSld>
@@ -2156,13 +1902,7 @@
       </p:grpSpPr>
       <p:sp>
         <p:nvSpPr>
-          <p:cNvPr id="2" name="Title 1">
-            <a:extLst>
-              <a:ext uri="{FF2B5EF4-FFF2-40B4-BE49-F238E27FC236}">
-                <a16:creationId xmlns:a16="http://schemas.microsoft.com/office/drawing/2014/main" id="{C2687DA0-A63A-9841-AEA1-4C4EF916CF04}"/>
-              </a:ext>
-            </a:extLst>
-          </p:cNvPr>
+          <p:cNvPr id="2" name="Title 1"/>
           <p:cNvSpPr>
             <a:spLocks noGrp="1"/>
           </p:cNvSpPr>
@@ -2172,8 +1912,8 @@
         </p:nvSpPr>
         <p:spPr>
           <a:xfrm>
-            <a:off x="839788" y="457200"/>
-            <a:ext cx="3932237" cy="1600200"/>
+            <a:off x="629841" y="457200"/>
+            <a:ext cx="2949178" cy="1600200"/>
           </a:xfrm>
         </p:spPr>
         <p:txBody>
@@ -2188,18 +1928,13 @@
               <a:rPr lang="en-US"/>
               <a:t>Click to edit Master title style</a:t>
             </a:r>
-          </a:p>
-        </p:txBody>
-      </p:sp>
-      <p:sp>
-        <p:nvSpPr>
-          <p:cNvPr id="3" name="Content Placeholder 2">
-            <a:extLst>
-              <a:ext uri="{FF2B5EF4-FFF2-40B4-BE49-F238E27FC236}">
-                <a16:creationId xmlns:a16="http://schemas.microsoft.com/office/drawing/2014/main" id="{4AFEFABC-A291-3F41-BD09-16B3756F91D7}"/>
-              </a:ext>
-            </a:extLst>
-          </p:cNvPr>
+            <a:endParaRPr lang="en-US" dirty="0"/>
+          </a:p>
+        </p:txBody>
+      </p:sp>
+      <p:sp>
+        <p:nvSpPr>
+          <p:cNvPr id="3" name="Content Placeholder 2"/>
           <p:cNvSpPr>
             <a:spLocks noGrp="1"/>
           </p:cNvSpPr>
@@ -2209,8 +1944,8 @@
         </p:nvSpPr>
         <p:spPr>
           <a:xfrm>
-            <a:off x="5183188" y="987425"/>
-            <a:ext cx="6172200" cy="4873625"/>
+            <a:off x="3887391" y="987426"/>
+            <a:ext cx="4629150" cy="4873625"/>
           </a:xfrm>
         </p:spPr>
         <p:txBody>
@@ -2278,18 +2013,13 @@
               <a:rPr lang="en-US"/>
               <a:t>Fifth level</a:t>
             </a:r>
-          </a:p>
-        </p:txBody>
-      </p:sp>
-      <p:sp>
-        <p:nvSpPr>
-          <p:cNvPr id="4" name="Text Placeholder 3">
-            <a:extLst>
-              <a:ext uri="{FF2B5EF4-FFF2-40B4-BE49-F238E27FC236}">
-                <a16:creationId xmlns:a16="http://schemas.microsoft.com/office/drawing/2014/main" id="{528A31CD-FCA5-5CF0-14F2-85254BF856C0}"/>
-              </a:ext>
-            </a:extLst>
-          </p:cNvPr>
+            <a:endParaRPr lang="en-US" dirty="0"/>
+          </a:p>
+        </p:txBody>
+      </p:sp>
+      <p:sp>
+        <p:nvSpPr>
+          <p:cNvPr id="4" name="Text Placeholder 3"/>
           <p:cNvSpPr>
             <a:spLocks noGrp="1"/>
           </p:cNvSpPr>
@@ -2299,8 +2029,8 @@
         </p:nvSpPr>
         <p:spPr>
           <a:xfrm>
-            <a:off x="839788" y="2057400"/>
-            <a:ext cx="3932237" cy="3811588"/>
+            <a:off x="629841" y="2057400"/>
+            <a:ext cx="2949178" cy="3811588"/>
           </a:xfrm>
         </p:spPr>
         <p:txBody>
@@ -2354,13 +2084,7 @@
       </p:sp>
       <p:sp>
         <p:nvSpPr>
-          <p:cNvPr id="5" name="Date Placeholder 4">
-            <a:extLst>
-              <a:ext uri="{FF2B5EF4-FFF2-40B4-BE49-F238E27FC236}">
-                <a16:creationId xmlns:a16="http://schemas.microsoft.com/office/drawing/2014/main" id="{070DDB05-1675-6DDB-FA69-D9856E74B9B3}"/>
-              </a:ext>
-            </a:extLst>
-          </p:cNvPr>
+          <p:cNvPr id="5" name="Date Placeholder 4"/>
           <p:cNvSpPr>
             <a:spLocks noGrp="1"/>
           </p:cNvSpPr>
@@ -2375,7 +2099,7 @@
           <a:p>
             <a:fld id="{A9CC02D6-97AE-0D43-90A4-072ED046C1C1}" type="datetimeFigureOut">
               <a:rPr lang="en-US" smtClean="0"/>
-              <a:t>9/14/26</a:t>
+              <a:t>9/30/26</a:t>
             </a:fld>
             <a:endParaRPr lang="en-US"/>
           </a:p>
@@ -2383,13 +2107,7 @@
       </p:sp>
       <p:sp>
         <p:nvSpPr>
-          <p:cNvPr id="6" name="Footer Placeholder 5">
-            <a:extLst>
-              <a:ext uri="{FF2B5EF4-FFF2-40B4-BE49-F238E27FC236}">
-                <a16:creationId xmlns:a16="http://schemas.microsoft.com/office/drawing/2014/main" id="{E936C103-453F-55A3-F7C2-CEE59357CF87}"/>
-              </a:ext>
-            </a:extLst>
-          </p:cNvPr>
+          <p:cNvPr id="6" name="Footer Placeholder 5"/>
           <p:cNvSpPr>
             <a:spLocks noGrp="1"/>
           </p:cNvSpPr>
@@ -2408,13 +2126,7 @@
       </p:sp>
       <p:sp>
         <p:nvSpPr>
-          <p:cNvPr id="7" name="Slide Number Placeholder 6">
-            <a:extLst>
-              <a:ext uri="{FF2B5EF4-FFF2-40B4-BE49-F238E27FC236}">
-                <a16:creationId xmlns:a16="http://schemas.microsoft.com/office/drawing/2014/main" id="{ACD46C94-D5E0-872E-7975-E1140BBBB3E3}"/>
-              </a:ext>
-            </a:extLst>
-          </p:cNvPr>
+          <p:cNvPr id="7" name="Slide Number Placeholder 6"/>
           <p:cNvSpPr>
             <a:spLocks noGrp="1"/>
           </p:cNvSpPr>
@@ -2438,7 +2150,7 @@
     </p:spTree>
     <p:extLst>
       <p:ext uri="{BB962C8B-B14F-4D97-AF65-F5344CB8AC3E}">
-        <p14:creationId xmlns:p14="http://schemas.microsoft.com/office/powerpoint/2010/main" val="1004270186"/>
+        <p14:creationId xmlns:p14="http://schemas.microsoft.com/office/powerpoint/2010/main" val="4081307905"/>
       </p:ext>
     </p:extLst>
   </p:cSld>
@@ -2467,13 +2179,7 @@
       </p:grpSpPr>
       <p:sp>
         <p:nvSpPr>
-          <p:cNvPr id="2" name="Title 1">
-            <a:extLst>
-              <a:ext uri="{FF2B5EF4-FFF2-40B4-BE49-F238E27FC236}">
-                <a16:creationId xmlns:a16="http://schemas.microsoft.com/office/drawing/2014/main" id="{81B706DB-8B0D-7488-040E-6F6E62807FA0}"/>
-              </a:ext>
-            </a:extLst>
-          </p:cNvPr>
+          <p:cNvPr id="2" name="Title 1"/>
           <p:cNvSpPr>
             <a:spLocks noGrp="1"/>
           </p:cNvSpPr>
@@ -2483,8 +2189,8 @@
         </p:nvSpPr>
         <p:spPr>
           <a:xfrm>
-            <a:off x="839788" y="457200"/>
-            <a:ext cx="3932237" cy="1600200"/>
+            <a:off x="629841" y="457200"/>
+            <a:ext cx="2949178" cy="1600200"/>
           </a:xfrm>
         </p:spPr>
         <p:txBody>
@@ -2499,20 +2205,15 @@
               <a:rPr lang="en-US"/>
               <a:t>Click to edit Master title style</a:t>
             </a:r>
-          </a:p>
-        </p:txBody>
-      </p:sp>
-      <p:sp>
-        <p:nvSpPr>
-          <p:cNvPr id="3" name="Picture Placeholder 2">
-            <a:extLst>
-              <a:ext uri="{FF2B5EF4-FFF2-40B4-BE49-F238E27FC236}">
-                <a16:creationId xmlns:a16="http://schemas.microsoft.com/office/drawing/2014/main" id="{4F36B088-7D71-5D27-343F-A0DCCAE57451}"/>
-              </a:ext>
-            </a:extLst>
-          </p:cNvPr>
-          <p:cNvSpPr>
-            <a:spLocks noGrp="1"/>
+            <a:endParaRPr lang="en-US" dirty="0"/>
+          </a:p>
+        </p:txBody>
+      </p:sp>
+      <p:sp>
+        <p:nvSpPr>
+          <p:cNvPr id="3" name="Picture Placeholder 2"/>
+          <p:cNvSpPr>
+            <a:spLocks noGrp="1" noChangeAspect="1"/>
           </p:cNvSpPr>
           <p:nvPr>
             <p:ph type="pic" idx="1"/>
@@ -2520,12 +2221,12 @@
         </p:nvSpPr>
         <p:spPr>
           <a:xfrm>
-            <a:off x="5183188" y="987425"/>
-            <a:ext cx="6172200" cy="4873625"/>
+            <a:off x="3887391" y="987426"/>
+            <a:ext cx="4629150" cy="4873625"/>
           </a:xfrm>
         </p:spPr>
         <p:txBody>
-          <a:bodyPr/>
+          <a:bodyPr anchor="t"/>
           <a:lstStyle>
             <a:lvl1pPr marL="0" indent="0">
               <a:buNone/>
@@ -2565,19 +2266,17 @@
             </a:lvl9pPr>
           </a:lstStyle>
           <a:p>
-            <a:endParaRPr lang="en-US"/>
-          </a:p>
-        </p:txBody>
-      </p:sp>
-      <p:sp>
-        <p:nvSpPr>
-          <p:cNvPr id="4" name="Text Placeholder 3">
-            <a:extLst>
-              <a:ext uri="{FF2B5EF4-FFF2-40B4-BE49-F238E27FC236}">
-                <a16:creationId xmlns:a16="http://schemas.microsoft.com/office/drawing/2014/main" id="{C00644F3-575B-7756-654C-263D4C8C0AF0}"/>
-              </a:ext>
-            </a:extLst>
-          </p:cNvPr>
+            <a:r>
+              <a:rPr lang="en-US"/>
+              <a:t>Click icon to add picture</a:t>
+            </a:r>
+            <a:endParaRPr lang="en-US" dirty="0"/>
+          </a:p>
+        </p:txBody>
+      </p:sp>
+      <p:sp>
+        <p:nvSpPr>
+          <p:cNvPr id="4" name="Text Placeholder 3"/>
           <p:cNvSpPr>
             <a:spLocks noGrp="1"/>
           </p:cNvSpPr>
@@ -2587,8 +2286,8 @@
         </p:nvSpPr>
         <p:spPr>
           <a:xfrm>
-            <a:off x="839788" y="2057400"/>
-            <a:ext cx="3932237" cy="3811588"/>
+            <a:off x="629841" y="2057400"/>
+            <a:ext cx="2949178" cy="3811588"/>
           </a:xfrm>
         </p:spPr>
         <p:txBody>
@@ -2642,13 +2341,7 @@
       </p:sp>
       <p:sp>
         <p:nvSpPr>
-          <p:cNvPr id="5" name="Date Placeholder 4">
-            <a:extLst>
-              <a:ext uri="{FF2B5EF4-FFF2-40B4-BE49-F238E27FC236}">
-                <a16:creationId xmlns:a16="http://schemas.microsoft.com/office/drawing/2014/main" id="{B1357379-1F04-1C7E-CD61-6BEFF4A292FE}"/>
-              </a:ext>
-            </a:extLst>
-          </p:cNvPr>
+          <p:cNvPr id="5" name="Date Placeholder 4"/>
           <p:cNvSpPr>
             <a:spLocks noGrp="1"/>
           </p:cNvSpPr>
@@ -2663,7 +2356,7 @@
           <a:p>
             <a:fld id="{A9CC02D6-97AE-0D43-90A4-072ED046C1C1}" type="datetimeFigureOut">
               <a:rPr lang="en-US" smtClean="0"/>
-              <a:t>9/14/26</a:t>
+              <a:t>9/30/26</a:t>
             </a:fld>
             <a:endParaRPr lang="en-US"/>
           </a:p>
@@ -2671,13 +2364,7 @@
       </p:sp>
       <p:sp>
         <p:nvSpPr>
-          <p:cNvPr id="6" name="Footer Placeholder 5">
-            <a:extLst>
-              <a:ext uri="{FF2B5EF4-FFF2-40B4-BE49-F238E27FC236}">
-                <a16:creationId xmlns:a16="http://schemas.microsoft.com/office/drawing/2014/main" id="{2698D595-B307-4952-3D16-A88B944A8AD4}"/>
-              </a:ext>
-            </a:extLst>
-          </p:cNvPr>
+          <p:cNvPr id="6" name="Footer Placeholder 5"/>
           <p:cNvSpPr>
             <a:spLocks noGrp="1"/>
           </p:cNvSpPr>
@@ -2696,13 +2383,7 @@
       </p:sp>
       <p:sp>
         <p:nvSpPr>
-          <p:cNvPr id="7" name="Slide Number Placeholder 6">
-            <a:extLst>
-              <a:ext uri="{FF2B5EF4-FFF2-40B4-BE49-F238E27FC236}">
-                <a16:creationId xmlns:a16="http://schemas.microsoft.com/office/drawing/2014/main" id="{61C061FE-37FB-A0FF-EDE8-A903CA5754D0}"/>
-              </a:ext>
-            </a:extLst>
-          </p:cNvPr>
+          <p:cNvPr id="7" name="Slide Number Placeholder 6"/>
           <p:cNvSpPr>
             <a:spLocks noGrp="1"/>
           </p:cNvSpPr>
@@ -2726,7 +2407,7 @@
     </p:spTree>
     <p:extLst>
       <p:ext uri="{BB962C8B-B14F-4D97-AF65-F5344CB8AC3E}">
-        <p14:creationId xmlns:p14="http://schemas.microsoft.com/office/powerpoint/2010/main" val="2183020973"/>
+        <p14:creationId xmlns:p14="http://schemas.microsoft.com/office/powerpoint/2010/main" val="818626368"/>
       </p:ext>
     </p:extLst>
   </p:cSld>
@@ -2760,13 +2441,7 @@
       </p:grpSpPr>
       <p:sp>
         <p:nvSpPr>
-          <p:cNvPr id="2" name="Title Placeholder 1">
-            <a:extLst>
-              <a:ext uri="{FF2B5EF4-FFF2-40B4-BE49-F238E27FC236}">
-                <a16:creationId xmlns:a16="http://schemas.microsoft.com/office/drawing/2014/main" id="{0FE77CE7-CCB2-9297-4327-231948F99A1D}"/>
-              </a:ext>
-            </a:extLst>
-          </p:cNvPr>
+          <p:cNvPr id="2" name="Title Placeholder 1"/>
           <p:cNvSpPr>
             <a:spLocks noGrp="1"/>
           </p:cNvSpPr>
@@ -2776,8 +2451,8 @@
         </p:nvSpPr>
         <p:spPr>
           <a:xfrm>
-            <a:off x="838200" y="365125"/>
-            <a:ext cx="10515600" cy="1325563"/>
+            <a:off x="628650" y="365126"/>
+            <a:ext cx="7886700" cy="1325563"/>
           </a:xfrm>
           <a:prstGeom prst="rect">
             <a:avLst/>
@@ -2793,18 +2468,13 @@
               <a:rPr lang="en-US"/>
               <a:t>Click to edit Master title style</a:t>
             </a:r>
-          </a:p>
-        </p:txBody>
-      </p:sp>
-      <p:sp>
-        <p:nvSpPr>
-          <p:cNvPr id="3" name="Text Placeholder 2">
-            <a:extLst>
-              <a:ext uri="{FF2B5EF4-FFF2-40B4-BE49-F238E27FC236}">
-                <a16:creationId xmlns:a16="http://schemas.microsoft.com/office/drawing/2014/main" id="{7DF60C0D-5C8A-80CD-6ABF-441589D87E03}"/>
-              </a:ext>
-            </a:extLst>
-          </p:cNvPr>
+            <a:endParaRPr lang="en-US" dirty="0"/>
+          </a:p>
+        </p:txBody>
+      </p:sp>
+      <p:sp>
+        <p:nvSpPr>
+          <p:cNvPr id="3" name="Text Placeholder 2"/>
           <p:cNvSpPr>
             <a:spLocks noGrp="1"/>
           </p:cNvSpPr>
@@ -2814,8 +2484,8 @@
         </p:nvSpPr>
         <p:spPr>
           <a:xfrm>
-            <a:off x="838200" y="1825625"/>
-            <a:ext cx="10515600" cy="4351338"/>
+            <a:off x="628650" y="1825625"/>
+            <a:ext cx="7886700" cy="4351338"/>
           </a:xfrm>
           <a:prstGeom prst="rect">
             <a:avLst/>
@@ -2860,18 +2530,13 @@
               <a:rPr lang="en-US"/>
               <a:t>Fifth level</a:t>
             </a:r>
-          </a:p>
-        </p:txBody>
-      </p:sp>
-      <p:sp>
-        <p:nvSpPr>
-          <p:cNvPr id="4" name="Date Placeholder 3">
-            <a:extLst>
-              <a:ext uri="{FF2B5EF4-FFF2-40B4-BE49-F238E27FC236}">
-                <a16:creationId xmlns:a16="http://schemas.microsoft.com/office/drawing/2014/main" id="{0537FDD4-02C7-E776-CFAE-DF148064CB4F}"/>
-              </a:ext>
-            </a:extLst>
-          </p:cNvPr>
+            <a:endParaRPr lang="en-US" dirty="0"/>
+          </a:p>
+        </p:txBody>
+      </p:sp>
+      <p:sp>
+        <p:nvSpPr>
+          <p:cNvPr id="4" name="Date Placeholder 3"/>
           <p:cNvSpPr>
             <a:spLocks noGrp="1"/>
           </p:cNvSpPr>
@@ -2881,8 +2546,8 @@
         </p:nvSpPr>
         <p:spPr>
           <a:xfrm>
-            <a:off x="838200" y="6356350"/>
-            <a:ext cx="2743200" cy="365125"/>
+            <a:off x="628650" y="6356351"/>
+            <a:ext cx="2057400" cy="365125"/>
           </a:xfrm>
           <a:prstGeom prst="rect">
             <a:avLst/>
@@ -2904,7 +2569,7 @@
           <a:p>
             <a:fld id="{A9CC02D6-97AE-0D43-90A4-072ED046C1C1}" type="datetimeFigureOut">
               <a:rPr lang="en-US" smtClean="0"/>
-              <a:t>9/14/26</a:t>
+              <a:t>9/30/26</a:t>
             </a:fld>
             <a:endParaRPr lang="en-US"/>
           </a:p>
@@ -2912,13 +2577,7 @@
       </p:sp>
       <p:sp>
         <p:nvSpPr>
-          <p:cNvPr id="5" name="Footer Placeholder 4">
-            <a:extLst>
-              <a:ext uri="{FF2B5EF4-FFF2-40B4-BE49-F238E27FC236}">
-                <a16:creationId xmlns:a16="http://schemas.microsoft.com/office/drawing/2014/main" id="{BC148FFC-A755-AA5C-CCC4-65C03BE6DE5E}"/>
-              </a:ext>
-            </a:extLst>
-          </p:cNvPr>
+          <p:cNvPr id="5" name="Footer Placeholder 4"/>
           <p:cNvSpPr>
             <a:spLocks noGrp="1"/>
           </p:cNvSpPr>
@@ -2928,8 +2587,8 @@
         </p:nvSpPr>
         <p:spPr>
           <a:xfrm>
-            <a:off x="4038600" y="6356350"/>
-            <a:ext cx="4114800" cy="365125"/>
+            <a:off x="3028950" y="6356351"/>
+            <a:ext cx="3086100" cy="365125"/>
           </a:xfrm>
           <a:prstGeom prst="rect">
             <a:avLst/>
@@ -2955,13 +2614,7 @@
       </p:sp>
       <p:sp>
         <p:nvSpPr>
-          <p:cNvPr id="6" name="Slide Number Placeholder 5">
-            <a:extLst>
-              <a:ext uri="{FF2B5EF4-FFF2-40B4-BE49-F238E27FC236}">
-                <a16:creationId xmlns:a16="http://schemas.microsoft.com/office/drawing/2014/main" id="{BE327625-9797-FA61-36B8-344D0BDD9B7B}"/>
-              </a:ext>
-            </a:extLst>
-          </p:cNvPr>
+          <p:cNvPr id="6" name="Slide Number Placeholder 5"/>
           <p:cNvSpPr>
             <a:spLocks noGrp="1"/>
           </p:cNvSpPr>
@@ -2971,8 +2624,8 @@
         </p:nvSpPr>
         <p:spPr>
           <a:xfrm>
-            <a:off x="8610600" y="6356350"/>
-            <a:ext cx="2743200" cy="365125"/>
+            <a:off x="6457950" y="6356351"/>
+            <a:ext cx="2057400" cy="365125"/>
           </a:xfrm>
           <a:prstGeom prst="rect">
             <a:avLst/>
@@ -3003,23 +2656,23 @@
     </p:spTree>
     <p:extLst>
       <p:ext uri="{BB962C8B-B14F-4D97-AF65-F5344CB8AC3E}">
-        <p14:creationId xmlns:p14="http://schemas.microsoft.com/office/powerpoint/2010/main" val="4182503211"/>
+        <p14:creationId xmlns:p14="http://schemas.microsoft.com/office/powerpoint/2010/main" val="1463594617"/>
       </p:ext>
     </p:extLst>
   </p:cSld>
   <p:clrMap bg1="lt1" tx1="dk1" bg2="lt2" tx2="dk2" accent1="accent1" accent2="accent2" accent3="accent3" accent4="accent4" accent5="accent5" accent6="accent6" hlink="hlink" folHlink="folHlink"/>
   <p:sldLayoutIdLst>
-    <p:sldLayoutId id="2147483649" r:id="rId1"/>
-    <p:sldLayoutId id="2147483650" r:id="rId2"/>
-    <p:sldLayoutId id="2147483651" r:id="rId3"/>
-    <p:sldLayoutId id="2147483652" r:id="rId4"/>
-    <p:sldLayoutId id="2147483653" r:id="rId5"/>
-    <p:sldLayoutId id="2147483654" r:id="rId6"/>
-    <p:sldLayoutId id="2147483655" r:id="rId7"/>
-    <p:sldLayoutId id="2147483656" r:id="rId8"/>
-    <p:sldLayoutId id="2147483657" r:id="rId9"/>
-    <p:sldLayoutId id="2147483658" r:id="rId10"/>
-    <p:sldLayoutId id="2147483659" r:id="rId11"/>
+    <p:sldLayoutId id="2147483661" r:id="rId1"/>
+    <p:sldLayoutId id="2147483662" r:id="rId2"/>
+    <p:sldLayoutId id="2147483663" r:id="rId3"/>
+    <p:sldLayoutId id="2147483664" r:id="rId4"/>
+    <p:sldLayoutId id="2147483665" r:id="rId5"/>
+    <p:sldLayoutId id="2147483666" r:id="rId6"/>
+    <p:sldLayoutId id="2147483667" r:id="rId7"/>
+    <p:sldLayoutId id="2147483668" r:id="rId8"/>
+    <p:sldLayoutId id="2147483669" r:id="rId9"/>
+    <p:sldLayoutId id="2147483670" r:id="rId10"/>
+    <p:sldLayoutId id="2147483671" r:id="rId11"/>
   </p:sldLayoutIdLst>
   <p:txStyles>
     <p:titleStyle>
@@ -3343,7 +2996,7 @@
         </p:blipFill>
         <p:spPr>
           <a:xfrm>
-            <a:off x="28834" y="3238500"/>
+            <a:off x="-1495166" y="3238500"/>
             <a:ext cx="4333875" cy="3467100"/>
           </a:xfrm>
           <a:prstGeom prst="rect">
@@ -3373,7 +3026,7 @@
         </p:blipFill>
         <p:spPr>
           <a:xfrm>
-            <a:off x="4350350" y="38100"/>
+            <a:off x="2826350" y="38100"/>
             <a:ext cx="7772400" cy="3238500"/>
           </a:xfrm>
           <a:prstGeom prst="rect">
@@ -3403,7 +3056,7 @@
         </p:blipFill>
         <p:spPr>
           <a:xfrm>
-            <a:off x="4350350" y="3429000"/>
+            <a:off x="2826350" y="3429000"/>
             <a:ext cx="7772400" cy="3238500"/>
           </a:xfrm>
           <a:prstGeom prst="rect">
@@ -3433,7 +3086,7 @@
         </p:blipFill>
         <p:spPr>
           <a:xfrm>
-            <a:off x="0" y="126141"/>
+            <a:off x="-1524000" y="126142"/>
             <a:ext cx="4593626" cy="3062417"/>
           </a:xfrm>
           <a:prstGeom prst="rect">
@@ -3454,10 +3107,160 @@
 </p:sld>
 </file>
 
+<file path=ppt/slides/slide2.xml><?xml version="1.0" encoding="utf-8"?>
+<p:sld xmlns:a="http://schemas.openxmlformats.org/drawingml/2006/main" xmlns:r="http://schemas.openxmlformats.org/officeDocument/2006/relationships" xmlns:p="http://schemas.openxmlformats.org/presentationml/2006/main">
+  <p:cSld>
+    <p:spTree>
+      <p:nvGrpSpPr>
+        <p:cNvPr id="1" name=""/>
+        <p:cNvGrpSpPr/>
+        <p:nvPr/>
+      </p:nvGrpSpPr>
+      <p:grpSpPr>
+        <a:xfrm>
+          <a:off x="0" y="0"/>
+          <a:ext cx="0" cy="0"/>
+          <a:chOff x="0" y="0"/>
+          <a:chExt cx="0" cy="0"/>
+        </a:xfrm>
+      </p:grpSpPr>
+      <p:pic>
+        <p:nvPicPr>
+          <p:cNvPr id="4" name="Picture 3">
+            <a:extLst>
+              <a:ext uri="{FF2B5EF4-FFF2-40B4-BE49-F238E27FC236}">
+                <a16:creationId xmlns:a16="http://schemas.microsoft.com/office/drawing/2014/main" id="{16FD44B0-9A97-4F45-CD2A-4C9D942F5671}"/>
+              </a:ext>
+            </a:extLst>
+          </p:cNvPr>
+          <p:cNvPicPr>
+            <a:picLocks noChangeAspect="1"/>
+          </p:cNvPicPr>
+          <p:nvPr/>
+        </p:nvPicPr>
+        <p:blipFill>
+          <a:blip r:embed="rId2"/>
+          <a:stretch>
+            <a:fillRect/>
+          </a:stretch>
+        </p:blipFill>
+        <p:spPr>
+          <a:xfrm>
+            <a:off x="-1495166" y="3238500"/>
+            <a:ext cx="4333875" cy="3467100"/>
+          </a:xfrm>
+          <a:prstGeom prst="rect">
+            <a:avLst/>
+          </a:prstGeom>
+        </p:spPr>
+      </p:pic>
+      <p:pic>
+        <p:nvPicPr>
+          <p:cNvPr id="5" name="Picture 4">
+            <a:extLst>
+              <a:ext uri="{FF2B5EF4-FFF2-40B4-BE49-F238E27FC236}">
+                <a16:creationId xmlns:a16="http://schemas.microsoft.com/office/drawing/2014/main" id="{5CE488E9-F6A8-1EDF-E9AA-316B0808F251}"/>
+              </a:ext>
+            </a:extLst>
+          </p:cNvPr>
+          <p:cNvPicPr>
+            <a:picLocks noChangeAspect="1"/>
+          </p:cNvPicPr>
+          <p:nvPr/>
+        </p:nvPicPr>
+        <p:blipFill>
+          <a:blip r:embed="rId3"/>
+          <a:stretch>
+            <a:fillRect/>
+          </a:stretch>
+        </p:blipFill>
+        <p:spPr>
+          <a:xfrm>
+            <a:off x="2826350" y="0"/>
+            <a:ext cx="7772400" cy="3238500"/>
+          </a:xfrm>
+          <a:prstGeom prst="rect">
+            <a:avLst/>
+          </a:prstGeom>
+        </p:spPr>
+      </p:pic>
+      <p:pic>
+        <p:nvPicPr>
+          <p:cNvPr id="6" name="Picture 5">
+            <a:extLst>
+              <a:ext uri="{FF2B5EF4-FFF2-40B4-BE49-F238E27FC236}">
+                <a16:creationId xmlns:a16="http://schemas.microsoft.com/office/drawing/2014/main" id="{52732970-339E-FDA0-1FEA-6A1244536282}"/>
+              </a:ext>
+            </a:extLst>
+          </p:cNvPr>
+          <p:cNvPicPr>
+            <a:picLocks noChangeAspect="1"/>
+          </p:cNvPicPr>
+          <p:nvPr/>
+        </p:nvPicPr>
+        <p:blipFill>
+          <a:blip r:embed="rId4"/>
+          <a:stretch>
+            <a:fillRect/>
+          </a:stretch>
+        </p:blipFill>
+        <p:spPr>
+          <a:xfrm>
+            <a:off x="2826350" y="3429000"/>
+            <a:ext cx="7772400" cy="3238500"/>
+          </a:xfrm>
+          <a:prstGeom prst="rect">
+            <a:avLst/>
+          </a:prstGeom>
+        </p:spPr>
+      </p:pic>
+      <p:pic>
+        <p:nvPicPr>
+          <p:cNvPr id="7" name="Picture 6">
+            <a:extLst>
+              <a:ext uri="{FF2B5EF4-FFF2-40B4-BE49-F238E27FC236}">
+                <a16:creationId xmlns:a16="http://schemas.microsoft.com/office/drawing/2014/main" id="{82AF6E57-5C2F-9E74-9620-1362285BAD81}"/>
+              </a:ext>
+            </a:extLst>
+          </p:cNvPr>
+          <p:cNvPicPr>
+            <a:picLocks noChangeAspect="1"/>
+          </p:cNvPicPr>
+          <p:nvPr/>
+        </p:nvPicPr>
+        <p:blipFill>
+          <a:blip r:embed="rId5"/>
+          <a:stretch>
+            <a:fillRect/>
+          </a:stretch>
+        </p:blipFill>
+        <p:spPr>
+          <a:xfrm>
+            <a:off x="-1524000" y="88042"/>
+            <a:ext cx="4593626" cy="3062417"/>
+          </a:xfrm>
+          <a:prstGeom prst="rect">
+            <a:avLst/>
+          </a:prstGeom>
+        </p:spPr>
+      </p:pic>
+    </p:spTree>
+    <p:extLst>
+      <p:ext uri="{BB962C8B-B14F-4D97-AF65-F5344CB8AC3E}">
+        <p14:creationId xmlns:p14="http://schemas.microsoft.com/office/powerpoint/2010/main" val="3358988704"/>
+      </p:ext>
+    </p:extLst>
+  </p:cSld>
+  <p:clrMapOvr>
+    <a:masterClrMapping/>
+  </p:clrMapOvr>
+</p:sld>
+</file>
+
 <file path=ppt/theme/theme1.xml><?xml version="1.0" encoding="utf-8"?>
 <a:theme xmlns:a="http://schemas.openxmlformats.org/drawingml/2006/main" name="Office Theme">
   <a:themeElements>
-    <a:clrScheme name="Office">
+    <a:clrScheme name="Office Theme">
       <a:dk1>
         <a:sysClr val="windowText" lastClr="000000"/>
       </a:dk1>
@@ -3495,7 +3298,7 @@
         <a:srgbClr val="96607D"/>
       </a:folHlink>
     </a:clrScheme>
-    <a:fontScheme name="Office">
+    <a:fontScheme name="Office Theme">
       <a:majorFont>
         <a:latin typeface="Aptos Display" panose="02110004020202020204"/>
         <a:ea typeface=""/>
@@ -3601,7 +3404,7 @@
         <a:font script="Tfng" typeface="Ebrima"/>
       </a:minorFont>
     </a:fontScheme>
-    <a:fmtScheme name="Office">
+    <a:fmtScheme name="Office Theme">
       <a:fillStyleLst>
         <a:solidFill>
           <a:schemeClr val="phClr"/>

</xml_diff>